<commit_message>
docs: restore Base Acc for original 3 models in Unified PPT table
</commit_message>
<xml_diff>
--- a/ColonoMind_System_Architecture_and_Results_FINAL.pptx
+++ b/ColonoMind_System_Architecture_and_Results_FINAL.pptx
@@ -4289,7 +4289,7 @@
                         <a:defRPr sz="1200"/>
                       </a:pPr>
                       <a:r>
-                        <a:t>-</a:t>
+                        <a:t>N/A</a:t>
                       </a:r>
                     </a:p>
                   </a:txBody>
@@ -4396,7 +4396,7 @@
                         <a:defRPr sz="1200"/>
                       </a:pPr>
                       <a:r>
-                        <a:t>-</a:t>
+                        <a:t>77.32%</a:t>
                       </a:r>
                     </a:p>
                   </a:txBody>
@@ -4503,7 +4503,7 @@
                         <a:defRPr sz="1200"/>
                       </a:pPr>
                       <a:r>
-                        <a:t>-</a:t>
+                        <a:t>N/A</a:t>
                       </a:r>
                     </a:p>
                   </a:txBody>
@@ -4610,7 +4610,7 @@
                         <a:defRPr sz="1200"/>
                       </a:pPr>
                       <a:r>
-                        <a:t>-</a:t>
+                        <a:t>76.21%</a:t>
                       </a:r>
                     </a:p>
                   </a:txBody>
@@ -4717,7 +4717,7 @@
                         <a:defRPr sz="1200"/>
                       </a:pPr>
                       <a:r>
-                        <a:t>-</a:t>
+                        <a:t>76.46%</a:t>
                       </a:r>
                     </a:p>
                   </a:txBody>

</xml_diff>

<commit_message>
docs: insert exact Base Accuracies for all 5 Unified models from DGX logs
</commit_message>
<xml_diff>
--- a/ColonoMind_System_Architecture_and_Results_FINAL.pptx
+++ b/ColonoMind_System_Architecture_and_Results_FINAL.pptx
@@ -4289,7 +4289,7 @@
                         <a:defRPr sz="1200"/>
                       </a:pPr>
                       <a:r>
-                        <a:t>N/A</a:t>
+                        <a:t>79.06%</a:t>
                       </a:r>
                     </a:p>
                   </a:txBody>
@@ -4396,7 +4396,7 @@
                         <a:defRPr sz="1200"/>
                       </a:pPr>
                       <a:r>
-                        <a:t>77.32%</a:t>
+                        <a:t>77.33%</a:t>
                       </a:r>
                     </a:p>
                   </a:txBody>
@@ -4503,7 +4503,7 @@
                         <a:defRPr sz="1200"/>
                       </a:pPr>
                       <a:r>
-                        <a:t>N/A</a:t>
+                        <a:t>77.82%</a:t>
                       </a:r>
                     </a:p>
                   </a:txBody>
@@ -4610,7 +4610,7 @@
                         <a:defRPr sz="1200"/>
                       </a:pPr>
                       <a:r>
-                        <a:t>76.21%</a:t>
+                        <a:t>76.41%</a:t>
                       </a:r>
                     </a:p>
                   </a:txBody>

</xml_diff>